<commit_message>
Restyle codes slide in the deck house style (Garamond, 00549F title and rule)
Native editable PowerPoint text built with pptxgenjs (codes_slide_deck.js),
replacing the image-based slide.

Co-Authored-By: Claude Fable 5 <noreply@anthropic.com>
Claude-Session: https://claude.ai/code/session_01DNzQPDcr3zfLTraMHUHqUn
</commit_message>
<xml_diff>
--- a/report/figures_deck/codes_slide.pptx
+++ b/report/figures_deck/codes_slide.pptx
@@ -854,6 +854,13 @@
 <file path=ppt/slides/slide1.xml><?xml version="1.0" encoding="utf-8"?>
 <p:sld xmlns:a="http://schemas.openxmlformats.org/drawingml/2006/main" xmlns:r="http://schemas.openxmlformats.org/officeDocument/2006/relationships" xmlns:p="http://schemas.openxmlformats.org/presentationml/2006/main">
   <p:cSld name="Slide 1">
+    <p:bg>
+      <p:bgPr>
+        <a:solidFill>
+          <a:srgbClr val="FFFFFF"/>
+        </a:solidFill>
+      </p:bgPr>
+    </p:bg>
     <p:spTree>
       <p:nvGrpSpPr>
         <p:cNvPr id="1" name=""/>
@@ -868,30 +875,1081 @@
           <a:chExt cx="0" cy="0"/>
         </a:xfrm>
       </p:grpSpPr>
-      <p:pic>
-        <p:nvPicPr>
-          <p:cNvPr id="2" name="Image 0" descr="/home/user/Alternative-Pathways----Quant/report/figures_deck/codes_slide.png">    </p:cNvPr>
-          <p:cNvPicPr>
-            <a:picLocks noChangeAspect="1"/>
-          </p:cNvPicPr>
+      <p:sp>
+        <p:nvSpPr>
+          <p:cNvPr id="2" name="Text 0"/>
+          <p:cNvSpPr/>
           <p:nvPr/>
-        </p:nvPicPr>
-        <p:blipFill>
-          <a:blip r:embed="rId1"/>
-          <a:stretch>
-            <a:fillRect/>
-          </a:stretch>
-        </p:blipFill>
+        </p:nvSpPr>
         <p:spPr>
           <a:xfrm>
-            <a:off x="0" y="0"/>
-            <a:ext cx="12188952" cy="6858000"/>
+            <a:off x="822960" y="457200"/>
+            <a:ext cx="10515600" cy="502920"/>
           </a:xfrm>
           <a:prstGeom prst="rect">
             <a:avLst/>
           </a:prstGeom>
+          <a:noFill/>
+          <a:ln/>
         </p:spPr>
-      </p:pic>
+        <p:txBody>
+          <a:bodyPr wrap="square" lIns="0" tIns="0" rIns="0" bIns="0" rtlCol="0" anchor="ctr"/>
+          <a:lstStyle/>
+          <a:p>
+            <a:pPr algn="l" indent="0" marL="0">
+              <a:buNone/>
+            </a:pPr>
+            <a:r>
+              <a:rPr lang="en-US" sz="2600" b="1" dirty="0">
+                <a:solidFill>
+                  <a:srgbClr val="00549F"/>
+                </a:solidFill>
+                <a:latin typeface="Garamond" pitchFamily="34" charset="0"/>
+                <a:ea typeface="Garamond" pitchFamily="34" charset="-122"/>
+                <a:cs typeface="Garamond" pitchFamily="34" charset="-120"/>
+              </a:rPr>
+              <a:t>Who Counts as a Teacher</a:t>
+            </a:r>
+            <a:endParaRPr lang="en-US" sz="2600" dirty="0"/>
+          </a:p>
+        </p:txBody>
+      </p:sp>
+      <p:sp>
+        <p:nvSpPr>
+          <p:cNvPr id="3" name="Shape 1"/>
+          <p:cNvSpPr/>
+          <p:nvPr/>
+        </p:nvSpPr>
+        <p:spPr>
+          <a:xfrm>
+            <a:off x="822960" y="1024128"/>
+            <a:ext cx="10543032" cy="0"/>
+          </a:xfrm>
+          <a:prstGeom prst="line">
+            <a:avLst/>
+          </a:prstGeom>
+          <a:noFill/>
+          <a:ln w="15240">
+            <a:solidFill>
+              <a:srgbClr val="00549F"/>
+            </a:solidFill>
+            <a:prstDash val="solid"/>
+          </a:ln>
+        </p:spPr>
+      </p:sp>
+      <p:sp>
+        <p:nvSpPr>
+          <p:cNvPr id="4" name="Text 2"/>
+          <p:cNvSpPr/>
+          <p:nvPr/>
+        </p:nvSpPr>
+        <p:spPr>
+          <a:xfrm>
+            <a:off x="822960" y="1115568"/>
+            <a:ext cx="10515600" cy="320040"/>
+          </a:xfrm>
+          <a:prstGeom prst="rect">
+            <a:avLst/>
+          </a:prstGeom>
+          <a:noFill/>
+          <a:ln/>
+        </p:spPr>
+        <p:txBody>
+          <a:bodyPr wrap="square" lIns="0" tIns="0" rIns="0" bIns="0" rtlCol="0" anchor="ctr"/>
+          <a:lstStyle/>
+          <a:p>
+            <a:pPr algn="l" indent="0" marL="0">
+              <a:buNone/>
+            </a:pPr>
+            <a:r>
+              <a:rPr lang="en-US" sz="1300" i="1" dirty="0">
+                <a:solidFill>
+                  <a:srgbClr val="6B7480"/>
+                </a:solidFill>
+                <a:latin typeface="Garamond" pitchFamily="34" charset="0"/>
+                <a:ea typeface="Garamond" pitchFamily="34" charset="-122"/>
+                <a:cs typeface="Garamond" pitchFamily="34" charset="-120"/>
+              </a:rPr>
+              <a:t>Occupation of the longest job held last year (CPS ASEC) — three Census classifications, 28 survey years</a:t>
+            </a:r>
+            <a:endParaRPr lang="en-US" sz="1300" dirty="0"/>
+          </a:p>
+        </p:txBody>
+      </p:sp>
+      <p:sp>
+        <p:nvSpPr>
+          <p:cNvPr id="5" name="Text 3"/>
+          <p:cNvSpPr/>
+          <p:nvPr/>
+        </p:nvSpPr>
+        <p:spPr>
+          <a:xfrm>
+            <a:off x="822960" y="1554480"/>
+            <a:ext cx="3657600" cy="2377440"/>
+          </a:xfrm>
+          <a:prstGeom prst="rect">
+            <a:avLst/>
+          </a:prstGeom>
+          <a:noFill/>
+          <a:ln/>
+        </p:spPr>
+        <p:txBody>
+          <a:bodyPr wrap="square" lIns="0" tIns="0" rIns="0" bIns="0" rtlCol="0" anchor="t"/>
+          <a:lstStyle/>
+          <a:p>
+            <a:pPr algn="l" indent="0" marL="0">
+              <a:buNone/>
+            </a:pPr>
+            <a:r>
+              <a:rPr lang="en-US" sz="1500" b="1" dirty="0">
+                <a:solidFill>
+                  <a:srgbClr val="00549F"/>
+                </a:solidFill>
+                <a:latin typeface="Garamond" pitchFamily="34" charset="0"/>
+                <a:ea typeface="Garamond" pitchFamily="34" charset="-122"/>
+                <a:cs typeface="Garamond" pitchFamily="34" charset="-120"/>
+              </a:rPr>
+              <a:t>Surveys 1998–2002</a:t>
+            </a:r>
+            <a:endParaRPr lang="en-US" sz="1500" dirty="0"/>
+          </a:p>
+          <a:p>
+            <a:pPr algn="l" indent="0" marL="0">
+              <a:buNone/>
+            </a:pPr>
+            <a:r>
+              <a:rPr lang="en-US" sz="1050" dirty="0">
+                <a:solidFill>
+                  <a:srgbClr val="6B7480"/>
+                </a:solidFill>
+                <a:latin typeface="Garamond" pitchFamily="34" charset="0"/>
+                <a:ea typeface="Garamond" pitchFamily="34" charset="-122"/>
+                <a:cs typeface="Garamond" pitchFamily="34" charset="-120"/>
+              </a:rPr>
+              <a:t>teaching years 1997–2001</a:t>
+            </a:r>
+            <a:endParaRPr lang="en-US" sz="1500" dirty="0"/>
+          </a:p>
+          <a:p>
+            <a:pPr algn="l" indent="0" marL="0">
+              <a:spcAft>
+                <a:spcPts val="800"/>
+              </a:spcAft>
+              <a:buNone/>
+            </a:pPr>
+            <a:r>
+              <a:rPr lang="en-US" sz="1050" i="1" dirty="0">
+                <a:solidFill>
+                  <a:srgbClr val="1A2430"/>
+                </a:solidFill>
+                <a:latin typeface="Garamond" pitchFamily="34" charset="0"/>
+                <a:ea typeface="Garamond" pitchFamily="34" charset="-122"/>
+                <a:cs typeface="Garamond" pitchFamily="34" charset="-120"/>
+              </a:rPr>
+              <a:t>1990 Census classification</a:t>
+            </a:r>
+            <a:endParaRPr lang="en-US" sz="1500" dirty="0"/>
+          </a:p>
+          <a:p>
+            <a:pPr algn="l" indent="0" marL="0">
+              <a:buNone/>
+            </a:pPr>
+            <a:r>
+              <a:rPr lang="en-US" sz="1050" b="1" dirty="0">
+                <a:solidFill>
+                  <a:srgbClr val="00549F"/>
+                </a:solidFill>
+                <a:latin typeface="Garamond" pitchFamily="34" charset="0"/>
+                <a:ea typeface="Garamond" pitchFamily="34" charset="-122"/>
+                <a:cs typeface="Garamond" pitchFamily="34" charset="-120"/>
+              </a:rPr>
+              <a:t>155   </a:t>
+            </a:r>
+            <a:pPr algn="l" indent="0" marL="0">
+              <a:spcAft>
+                <a:spcPts val="500"/>
+              </a:spcAft>
+              <a:buNone/>
+            </a:pPr>
+            <a:r>
+              <a:rPr lang="en-US" sz="1050" dirty="0">
+                <a:solidFill>
+                  <a:srgbClr val="1A2430"/>
+                </a:solidFill>
+                <a:latin typeface="Garamond" pitchFamily="34" charset="0"/>
+                <a:ea typeface="Garamond" pitchFamily="34" charset="-122"/>
+                <a:cs typeface="Garamond" pitchFamily="34" charset="-120"/>
+              </a:rPr>
+              <a:t>Teachers, prekindergarten and kindergarten</a:t>
+            </a:r>
+            <a:endParaRPr lang="en-US" sz="1500" dirty="0"/>
+          </a:p>
+          <a:p>
+            <a:pPr algn="l" indent="0" marL="0">
+              <a:buNone/>
+            </a:pPr>
+            <a:r>
+              <a:rPr lang="en-US" sz="1050" b="1" dirty="0">
+                <a:solidFill>
+                  <a:srgbClr val="00549F"/>
+                </a:solidFill>
+                <a:latin typeface="Garamond" pitchFamily="34" charset="0"/>
+                <a:ea typeface="Garamond" pitchFamily="34" charset="-122"/>
+                <a:cs typeface="Garamond" pitchFamily="34" charset="-120"/>
+              </a:rPr>
+              <a:t>156   </a:t>
+            </a:r>
+            <a:pPr algn="l" indent="0" marL="0">
+              <a:spcAft>
+                <a:spcPts val="500"/>
+              </a:spcAft>
+              <a:buNone/>
+            </a:pPr>
+            <a:r>
+              <a:rPr lang="en-US" sz="1050" dirty="0">
+                <a:solidFill>
+                  <a:srgbClr val="1A2430"/>
+                </a:solidFill>
+                <a:latin typeface="Garamond" pitchFamily="34" charset="0"/>
+                <a:ea typeface="Garamond" pitchFamily="34" charset="-122"/>
+                <a:cs typeface="Garamond" pitchFamily="34" charset="-120"/>
+              </a:rPr>
+              <a:t>Teachers, elementary school†</a:t>
+            </a:r>
+            <a:endParaRPr lang="en-US" sz="1500" dirty="0"/>
+          </a:p>
+          <a:p>
+            <a:pPr algn="l" indent="0" marL="0">
+              <a:buNone/>
+            </a:pPr>
+            <a:r>
+              <a:rPr lang="en-US" sz="1050" b="1" dirty="0">
+                <a:solidFill>
+                  <a:srgbClr val="00549F"/>
+                </a:solidFill>
+                <a:latin typeface="Garamond" pitchFamily="34" charset="0"/>
+                <a:ea typeface="Garamond" pitchFamily="34" charset="-122"/>
+                <a:cs typeface="Garamond" pitchFamily="34" charset="-120"/>
+              </a:rPr>
+              <a:t>157   </a:t>
+            </a:r>
+            <a:pPr algn="l" indent="0" marL="0">
+              <a:spcAft>
+                <a:spcPts val="500"/>
+              </a:spcAft>
+              <a:buNone/>
+            </a:pPr>
+            <a:r>
+              <a:rPr lang="en-US" sz="1050" dirty="0">
+                <a:solidFill>
+                  <a:srgbClr val="1A2430"/>
+                </a:solidFill>
+                <a:latin typeface="Garamond" pitchFamily="34" charset="0"/>
+                <a:ea typeface="Garamond" pitchFamily="34" charset="-122"/>
+                <a:cs typeface="Garamond" pitchFamily="34" charset="-120"/>
+              </a:rPr>
+              <a:t>Teachers, secondary school†</a:t>
+            </a:r>
+            <a:endParaRPr lang="en-US" sz="1500" dirty="0"/>
+          </a:p>
+          <a:p>
+            <a:pPr algn="l" indent="0" marL="0">
+              <a:buNone/>
+            </a:pPr>
+            <a:r>
+              <a:rPr lang="en-US" sz="1050" b="1" dirty="0">
+                <a:solidFill>
+                  <a:srgbClr val="00549F"/>
+                </a:solidFill>
+                <a:latin typeface="Garamond" pitchFamily="34" charset="0"/>
+                <a:ea typeface="Garamond" pitchFamily="34" charset="-122"/>
+                <a:cs typeface="Garamond" pitchFamily="34" charset="-120"/>
+              </a:rPr>
+              <a:t>158   </a:t>
+            </a:r>
+            <a:pPr algn="l" indent="0" marL="0">
+              <a:spcAft>
+                <a:spcPts val="500"/>
+              </a:spcAft>
+              <a:buNone/>
+            </a:pPr>
+            <a:r>
+              <a:rPr lang="en-US" sz="1050" dirty="0">
+                <a:solidFill>
+                  <a:srgbClr val="1A2430"/>
+                </a:solidFill>
+                <a:latin typeface="Garamond" pitchFamily="34" charset="0"/>
+                <a:ea typeface="Garamond" pitchFamily="34" charset="-122"/>
+                <a:cs typeface="Garamond" pitchFamily="34" charset="-120"/>
+              </a:rPr>
+              <a:t>Teachers, special education</a:t>
+            </a:r>
+            <a:endParaRPr lang="en-US" sz="1500" dirty="0"/>
+          </a:p>
+          <a:p>
+            <a:pPr algn="l" indent="0" marL="0">
+              <a:buNone/>
+            </a:pPr>
+            <a:r>
+              <a:rPr lang="en-US" sz="1050" b="1" dirty="0">
+                <a:solidFill>
+                  <a:srgbClr val="00549F"/>
+                </a:solidFill>
+                <a:latin typeface="Garamond" pitchFamily="34" charset="0"/>
+                <a:ea typeface="Garamond" pitchFamily="34" charset="-122"/>
+                <a:cs typeface="Garamond" pitchFamily="34" charset="-120"/>
+              </a:rPr>
+              <a:t>159   </a:t>
+            </a:r>
+            <a:pPr algn="l" indent="0" marL="0">
+              <a:spcAft>
+                <a:spcPts val="500"/>
+              </a:spcAft>
+              <a:buNone/>
+            </a:pPr>
+            <a:r>
+              <a:rPr lang="en-US" sz="1050" dirty="0">
+                <a:solidFill>
+                  <a:srgbClr val="1A2430"/>
+                </a:solidFill>
+                <a:latin typeface="Garamond" pitchFamily="34" charset="0"/>
+                <a:ea typeface="Garamond" pitchFamily="34" charset="-122"/>
+                <a:cs typeface="Garamond" pitchFamily="34" charset="-120"/>
+              </a:rPr>
+              <a:t>Teachers, n.e.c. (not elsewhere classified)</a:t>
+            </a:r>
+            <a:endParaRPr lang="en-US" sz="1500" dirty="0"/>
+          </a:p>
+        </p:txBody>
+      </p:sp>
+      <p:sp>
+        <p:nvSpPr>
+          <p:cNvPr id="6" name="Text 4"/>
+          <p:cNvSpPr/>
+          <p:nvPr/>
+        </p:nvSpPr>
+        <p:spPr>
+          <a:xfrm>
+            <a:off x="4617720" y="1554480"/>
+            <a:ext cx="3657600" cy="2377440"/>
+          </a:xfrm>
+          <a:prstGeom prst="rect">
+            <a:avLst/>
+          </a:prstGeom>
+          <a:noFill/>
+          <a:ln/>
+        </p:spPr>
+        <p:txBody>
+          <a:bodyPr wrap="square" lIns="0" tIns="0" rIns="0" bIns="0" rtlCol="0" anchor="t"/>
+          <a:lstStyle/>
+          <a:p>
+            <a:pPr algn="l" indent="0" marL="0">
+              <a:buNone/>
+            </a:pPr>
+            <a:r>
+              <a:rPr lang="en-US" sz="1500" b="1" dirty="0">
+                <a:solidFill>
+                  <a:srgbClr val="00549F"/>
+                </a:solidFill>
+                <a:latin typeface="Garamond" pitchFamily="34" charset="0"/>
+                <a:ea typeface="Garamond" pitchFamily="34" charset="-122"/>
+                <a:cs typeface="Garamond" pitchFamily="34" charset="-120"/>
+              </a:rPr>
+              <a:t>Surveys 2003–2019</a:t>
+            </a:r>
+            <a:endParaRPr lang="en-US" sz="1500" dirty="0"/>
+          </a:p>
+          <a:p>
+            <a:pPr algn="l" indent="0" marL="0">
+              <a:buNone/>
+            </a:pPr>
+            <a:r>
+              <a:rPr lang="en-US" sz="1050" dirty="0">
+                <a:solidFill>
+                  <a:srgbClr val="6B7480"/>
+                </a:solidFill>
+                <a:latin typeface="Garamond" pitchFamily="34" charset="0"/>
+                <a:ea typeface="Garamond" pitchFamily="34" charset="-122"/>
+                <a:cs typeface="Garamond" pitchFamily="34" charset="-120"/>
+              </a:rPr>
+              <a:t>teaching years 2002–2018</a:t>
+            </a:r>
+            <a:endParaRPr lang="en-US" sz="1500" dirty="0"/>
+          </a:p>
+          <a:p>
+            <a:pPr algn="l" indent="0" marL="0">
+              <a:spcAft>
+                <a:spcPts val="800"/>
+              </a:spcAft>
+              <a:buNone/>
+            </a:pPr>
+            <a:r>
+              <a:rPr lang="en-US" sz="1050" i="1" dirty="0">
+                <a:solidFill>
+                  <a:srgbClr val="1A2430"/>
+                </a:solidFill>
+                <a:latin typeface="Garamond" pitchFamily="34" charset="0"/>
+                <a:ea typeface="Garamond" pitchFamily="34" charset="-122"/>
+                <a:cs typeface="Garamond" pitchFamily="34" charset="-120"/>
+              </a:rPr>
+              <a:t>2002/2010 Census classification (SOC)</a:t>
+            </a:r>
+            <a:endParaRPr lang="en-US" sz="1500" dirty="0"/>
+          </a:p>
+          <a:p>
+            <a:pPr algn="l" indent="0" marL="0">
+              <a:buNone/>
+            </a:pPr>
+            <a:r>
+              <a:rPr lang="en-US" sz="1050" b="1" dirty="0">
+                <a:solidFill>
+                  <a:srgbClr val="00549F"/>
+                </a:solidFill>
+                <a:latin typeface="Garamond" pitchFamily="34" charset="0"/>
+                <a:ea typeface="Garamond" pitchFamily="34" charset="-122"/>
+                <a:cs typeface="Garamond" pitchFamily="34" charset="-120"/>
+              </a:rPr>
+              <a:t>2300   </a:t>
+            </a:r>
+            <a:pPr algn="l" indent="0" marL="0">
+              <a:spcAft>
+                <a:spcPts val="500"/>
+              </a:spcAft>
+              <a:buNone/>
+            </a:pPr>
+            <a:r>
+              <a:rPr lang="en-US" sz="1050" dirty="0">
+                <a:solidFill>
+                  <a:srgbClr val="1A2430"/>
+                </a:solidFill>
+                <a:latin typeface="Garamond" pitchFamily="34" charset="0"/>
+                <a:ea typeface="Garamond" pitchFamily="34" charset="-122"/>
+                <a:cs typeface="Garamond" pitchFamily="34" charset="-120"/>
+              </a:rPr>
+              <a:t>Preschool and kindergarten teachers</a:t>
+            </a:r>
+            <a:endParaRPr lang="en-US" sz="1500" dirty="0"/>
+          </a:p>
+          <a:p>
+            <a:pPr algn="l" indent="0" marL="0">
+              <a:buNone/>
+            </a:pPr>
+            <a:r>
+              <a:rPr lang="en-US" sz="1050" b="1" dirty="0">
+                <a:solidFill>
+                  <a:srgbClr val="00549F"/>
+                </a:solidFill>
+                <a:latin typeface="Garamond" pitchFamily="34" charset="0"/>
+                <a:ea typeface="Garamond" pitchFamily="34" charset="-122"/>
+                <a:cs typeface="Garamond" pitchFamily="34" charset="-120"/>
+              </a:rPr>
+              <a:t>2310   </a:t>
+            </a:r>
+            <a:pPr algn="l" indent="0" marL="0">
+              <a:spcAft>
+                <a:spcPts val="500"/>
+              </a:spcAft>
+              <a:buNone/>
+            </a:pPr>
+            <a:r>
+              <a:rPr lang="en-US" sz="1050" dirty="0">
+                <a:solidFill>
+                  <a:srgbClr val="1A2430"/>
+                </a:solidFill>
+                <a:latin typeface="Garamond" pitchFamily="34" charset="0"/>
+                <a:ea typeface="Garamond" pitchFamily="34" charset="-122"/>
+                <a:cs typeface="Garamond" pitchFamily="34" charset="-120"/>
+              </a:rPr>
+              <a:t>Elementary and middle school teachers†</a:t>
+            </a:r>
+            <a:endParaRPr lang="en-US" sz="1500" dirty="0"/>
+          </a:p>
+          <a:p>
+            <a:pPr algn="l" indent="0" marL="0">
+              <a:buNone/>
+            </a:pPr>
+            <a:r>
+              <a:rPr lang="en-US" sz="1050" b="1" dirty="0">
+                <a:solidFill>
+                  <a:srgbClr val="00549F"/>
+                </a:solidFill>
+                <a:latin typeface="Garamond" pitchFamily="34" charset="0"/>
+                <a:ea typeface="Garamond" pitchFamily="34" charset="-122"/>
+                <a:cs typeface="Garamond" pitchFamily="34" charset="-120"/>
+              </a:rPr>
+              <a:t>2320   </a:t>
+            </a:r>
+            <a:pPr algn="l" indent="0" marL="0">
+              <a:spcAft>
+                <a:spcPts val="500"/>
+              </a:spcAft>
+              <a:buNone/>
+            </a:pPr>
+            <a:r>
+              <a:rPr lang="en-US" sz="1050" dirty="0">
+                <a:solidFill>
+                  <a:srgbClr val="1A2430"/>
+                </a:solidFill>
+                <a:latin typeface="Garamond" pitchFamily="34" charset="0"/>
+                <a:ea typeface="Garamond" pitchFamily="34" charset="-122"/>
+                <a:cs typeface="Garamond" pitchFamily="34" charset="-120"/>
+              </a:rPr>
+              <a:t>Secondary school teachers</a:t>
+            </a:r>
+            <a:endParaRPr lang="en-US" sz="1500" dirty="0"/>
+          </a:p>
+          <a:p>
+            <a:pPr algn="l" indent="0" marL="0">
+              <a:buNone/>
+            </a:pPr>
+            <a:r>
+              <a:rPr lang="en-US" sz="1050" b="1" dirty="0">
+                <a:solidFill>
+                  <a:srgbClr val="00549F"/>
+                </a:solidFill>
+                <a:latin typeface="Garamond" pitchFamily="34" charset="0"/>
+                <a:ea typeface="Garamond" pitchFamily="34" charset="-122"/>
+                <a:cs typeface="Garamond" pitchFamily="34" charset="-120"/>
+              </a:rPr>
+              <a:t>2330   </a:t>
+            </a:r>
+            <a:pPr algn="l" indent="0" marL="0">
+              <a:spcAft>
+                <a:spcPts val="500"/>
+              </a:spcAft>
+              <a:buNone/>
+            </a:pPr>
+            <a:r>
+              <a:rPr lang="en-US" sz="1050" dirty="0">
+                <a:solidFill>
+                  <a:srgbClr val="1A2430"/>
+                </a:solidFill>
+                <a:latin typeface="Garamond" pitchFamily="34" charset="0"/>
+                <a:ea typeface="Garamond" pitchFamily="34" charset="-122"/>
+                <a:cs typeface="Garamond" pitchFamily="34" charset="-120"/>
+              </a:rPr>
+              <a:t>Special education teachers</a:t>
+            </a:r>
+            <a:endParaRPr lang="en-US" sz="1500" dirty="0"/>
+          </a:p>
+          <a:p>
+            <a:pPr algn="l" indent="0" marL="0">
+              <a:buNone/>
+            </a:pPr>
+            <a:r>
+              <a:rPr lang="en-US" sz="1050" b="1" dirty="0">
+                <a:solidFill>
+                  <a:srgbClr val="00549F"/>
+                </a:solidFill>
+                <a:latin typeface="Garamond" pitchFamily="34" charset="0"/>
+                <a:ea typeface="Garamond" pitchFamily="34" charset="-122"/>
+                <a:cs typeface="Garamond" pitchFamily="34" charset="-120"/>
+              </a:rPr>
+              <a:t>2340   </a:t>
+            </a:r>
+            <a:pPr algn="l" indent="0" marL="0">
+              <a:spcAft>
+                <a:spcPts val="500"/>
+              </a:spcAft>
+              <a:buNone/>
+            </a:pPr>
+            <a:r>
+              <a:rPr lang="en-US" sz="1050" dirty="0">
+                <a:solidFill>
+                  <a:srgbClr val="1A2430"/>
+                </a:solidFill>
+                <a:latin typeface="Garamond" pitchFamily="34" charset="0"/>
+                <a:ea typeface="Garamond" pitchFamily="34" charset="-122"/>
+                <a:cs typeface="Garamond" pitchFamily="34" charset="-120"/>
+              </a:rPr>
+              <a:t>Other teachers and instructors</a:t>
+            </a:r>
+            <a:endParaRPr lang="en-US" sz="1500" dirty="0"/>
+          </a:p>
+        </p:txBody>
+      </p:sp>
+      <p:sp>
+        <p:nvSpPr>
+          <p:cNvPr id="7" name="Text 5"/>
+          <p:cNvSpPr/>
+          <p:nvPr/>
+        </p:nvSpPr>
+        <p:spPr>
+          <a:xfrm>
+            <a:off x="8412480" y="1554480"/>
+            <a:ext cx="3657600" cy="2377440"/>
+          </a:xfrm>
+          <a:prstGeom prst="rect">
+            <a:avLst/>
+          </a:prstGeom>
+          <a:noFill/>
+          <a:ln/>
+        </p:spPr>
+        <p:txBody>
+          <a:bodyPr wrap="square" lIns="0" tIns="0" rIns="0" bIns="0" rtlCol="0" anchor="t"/>
+          <a:lstStyle/>
+          <a:p>
+            <a:pPr algn="l" indent="0" marL="0">
+              <a:buNone/>
+            </a:pPr>
+            <a:r>
+              <a:rPr lang="en-US" sz="1500" b="1" dirty="0">
+                <a:solidFill>
+                  <a:srgbClr val="00549F"/>
+                </a:solidFill>
+                <a:latin typeface="Garamond" pitchFamily="34" charset="0"/>
+                <a:ea typeface="Garamond" pitchFamily="34" charset="-122"/>
+                <a:cs typeface="Garamond" pitchFamily="34" charset="-120"/>
+              </a:rPr>
+              <a:t>Surveys 2020–2025</a:t>
+            </a:r>
+            <a:endParaRPr lang="en-US" sz="1500" dirty="0"/>
+          </a:p>
+          <a:p>
+            <a:pPr algn="l" indent="0" marL="0">
+              <a:buNone/>
+            </a:pPr>
+            <a:r>
+              <a:rPr lang="en-US" sz="1050" dirty="0">
+                <a:solidFill>
+                  <a:srgbClr val="6B7480"/>
+                </a:solidFill>
+                <a:latin typeface="Garamond" pitchFamily="34" charset="0"/>
+                <a:ea typeface="Garamond" pitchFamily="34" charset="-122"/>
+                <a:cs typeface="Garamond" pitchFamily="34" charset="-120"/>
+              </a:rPr>
+              <a:t>teaching years 2019–2024</a:t>
+            </a:r>
+            <a:endParaRPr lang="en-US" sz="1500" dirty="0"/>
+          </a:p>
+          <a:p>
+            <a:pPr algn="l" indent="0" marL="0">
+              <a:spcAft>
+                <a:spcPts val="800"/>
+              </a:spcAft>
+              <a:buNone/>
+            </a:pPr>
+            <a:r>
+              <a:rPr lang="en-US" sz="1050" i="1" dirty="0">
+                <a:solidFill>
+                  <a:srgbClr val="1A2430"/>
+                </a:solidFill>
+                <a:latin typeface="Garamond" pitchFamily="34" charset="0"/>
+                <a:ea typeface="Garamond" pitchFamily="34" charset="-122"/>
+                <a:cs typeface="Garamond" pitchFamily="34" charset="-120"/>
+              </a:rPr>
+              <a:t>2018 Census classification (SOC 2018)</a:t>
+            </a:r>
+            <a:endParaRPr lang="en-US" sz="1500" dirty="0"/>
+          </a:p>
+          <a:p>
+            <a:pPr algn="l" indent="0" marL="0">
+              <a:buNone/>
+            </a:pPr>
+            <a:r>
+              <a:rPr lang="en-US" sz="1050" b="1" dirty="0">
+                <a:solidFill>
+                  <a:srgbClr val="00549F"/>
+                </a:solidFill>
+                <a:latin typeface="Garamond" pitchFamily="34" charset="0"/>
+                <a:ea typeface="Garamond" pitchFamily="34" charset="-122"/>
+                <a:cs typeface="Garamond" pitchFamily="34" charset="-120"/>
+              </a:rPr>
+              <a:t>2300   </a:t>
+            </a:r>
+            <a:pPr algn="l" indent="0" marL="0">
+              <a:spcAft>
+                <a:spcPts val="500"/>
+              </a:spcAft>
+              <a:buNone/>
+            </a:pPr>
+            <a:r>
+              <a:rPr lang="en-US" sz="1050" dirty="0">
+                <a:solidFill>
+                  <a:srgbClr val="1A2430"/>
+                </a:solidFill>
+                <a:latin typeface="Garamond" pitchFamily="34" charset="0"/>
+                <a:ea typeface="Garamond" pitchFamily="34" charset="-122"/>
+                <a:cs typeface="Garamond" pitchFamily="34" charset="-120"/>
+              </a:rPr>
+              <a:t>Preschool and kindergarten teachers</a:t>
+            </a:r>
+            <a:endParaRPr lang="en-US" sz="1500" dirty="0"/>
+          </a:p>
+          <a:p>
+            <a:pPr algn="l" indent="0" marL="0">
+              <a:buNone/>
+            </a:pPr>
+            <a:r>
+              <a:rPr lang="en-US" sz="1050" b="1" dirty="0">
+                <a:solidFill>
+                  <a:srgbClr val="00549F"/>
+                </a:solidFill>
+                <a:latin typeface="Garamond" pitchFamily="34" charset="0"/>
+                <a:ea typeface="Garamond" pitchFamily="34" charset="-122"/>
+                <a:cs typeface="Garamond" pitchFamily="34" charset="-120"/>
+              </a:rPr>
+              <a:t>2310   </a:t>
+            </a:r>
+            <a:pPr algn="l" indent="0" marL="0">
+              <a:spcAft>
+                <a:spcPts val="500"/>
+              </a:spcAft>
+              <a:buNone/>
+            </a:pPr>
+            <a:r>
+              <a:rPr lang="en-US" sz="1050" dirty="0">
+                <a:solidFill>
+                  <a:srgbClr val="1A2430"/>
+                </a:solidFill>
+                <a:latin typeface="Garamond" pitchFamily="34" charset="0"/>
+                <a:ea typeface="Garamond" pitchFamily="34" charset="-122"/>
+                <a:cs typeface="Garamond" pitchFamily="34" charset="-120"/>
+              </a:rPr>
+              <a:t>Elementary and middle school teachers†</a:t>
+            </a:r>
+            <a:endParaRPr lang="en-US" sz="1500" dirty="0"/>
+          </a:p>
+          <a:p>
+            <a:pPr algn="l" indent="0" marL="0">
+              <a:buNone/>
+            </a:pPr>
+            <a:r>
+              <a:rPr lang="en-US" sz="1050" b="1" dirty="0">
+                <a:solidFill>
+                  <a:srgbClr val="00549F"/>
+                </a:solidFill>
+                <a:latin typeface="Garamond" pitchFamily="34" charset="0"/>
+                <a:ea typeface="Garamond" pitchFamily="34" charset="-122"/>
+                <a:cs typeface="Garamond" pitchFamily="34" charset="-120"/>
+              </a:rPr>
+              <a:t>2320   </a:t>
+            </a:r>
+            <a:pPr algn="l" indent="0" marL="0">
+              <a:spcAft>
+                <a:spcPts val="500"/>
+              </a:spcAft>
+              <a:buNone/>
+            </a:pPr>
+            <a:r>
+              <a:rPr lang="en-US" sz="1050" dirty="0">
+                <a:solidFill>
+                  <a:srgbClr val="1A2430"/>
+                </a:solidFill>
+                <a:latin typeface="Garamond" pitchFamily="34" charset="0"/>
+                <a:ea typeface="Garamond" pitchFamily="34" charset="-122"/>
+                <a:cs typeface="Garamond" pitchFamily="34" charset="-120"/>
+              </a:rPr>
+              <a:t>Secondary school teachers</a:t>
+            </a:r>
+            <a:endParaRPr lang="en-US" sz="1500" dirty="0"/>
+          </a:p>
+          <a:p>
+            <a:pPr algn="l" indent="0" marL="0">
+              <a:buNone/>
+            </a:pPr>
+            <a:r>
+              <a:rPr lang="en-US" sz="1050" b="1" dirty="0">
+                <a:solidFill>
+                  <a:srgbClr val="00549F"/>
+                </a:solidFill>
+                <a:latin typeface="Garamond" pitchFamily="34" charset="0"/>
+                <a:ea typeface="Garamond" pitchFamily="34" charset="-122"/>
+                <a:cs typeface="Garamond" pitchFamily="34" charset="-120"/>
+              </a:rPr>
+              <a:t>2330   </a:t>
+            </a:r>
+            <a:pPr algn="l" indent="0" marL="0">
+              <a:spcAft>
+                <a:spcPts val="500"/>
+              </a:spcAft>
+              <a:buNone/>
+            </a:pPr>
+            <a:r>
+              <a:rPr lang="en-US" sz="1050" dirty="0">
+                <a:solidFill>
+                  <a:srgbClr val="1A2430"/>
+                </a:solidFill>
+                <a:latin typeface="Garamond" pitchFamily="34" charset="0"/>
+                <a:ea typeface="Garamond" pitchFamily="34" charset="-122"/>
+                <a:cs typeface="Garamond" pitchFamily="34" charset="-120"/>
+              </a:rPr>
+              <a:t>Special education teachers</a:t>
+            </a:r>
+            <a:endParaRPr lang="en-US" sz="1500" dirty="0"/>
+          </a:p>
+          <a:p>
+            <a:pPr algn="l" indent="0" marL="0">
+              <a:buNone/>
+            </a:pPr>
+            <a:r>
+              <a:rPr lang="en-US" sz="1050" b="1" dirty="0">
+                <a:solidFill>
+                  <a:srgbClr val="00549F"/>
+                </a:solidFill>
+                <a:latin typeface="Garamond" pitchFamily="34" charset="0"/>
+                <a:ea typeface="Garamond" pitchFamily="34" charset="-122"/>
+                <a:cs typeface="Garamond" pitchFamily="34" charset="-120"/>
+              </a:rPr>
+              <a:t>2360   </a:t>
+            </a:r>
+            <a:pPr algn="l" indent="0" marL="0">
+              <a:spcAft>
+                <a:spcPts val="500"/>
+              </a:spcAft>
+              <a:buNone/>
+            </a:pPr>
+            <a:r>
+              <a:rPr lang="en-US" sz="1050" dirty="0">
+                <a:solidFill>
+                  <a:srgbClr val="1A2430"/>
+                </a:solidFill>
+                <a:latin typeface="Garamond" pitchFamily="34" charset="0"/>
+                <a:ea typeface="Garamond" pitchFamily="34" charset="-122"/>
+                <a:cs typeface="Garamond" pitchFamily="34" charset="-120"/>
+              </a:rPr>
+              <a:t>Other teachers and instructors</a:t>
+            </a:r>
+            <a:endParaRPr lang="en-US" sz="1500" dirty="0"/>
+          </a:p>
+        </p:txBody>
+      </p:sp>
+      <p:sp>
+        <p:nvSpPr>
+          <p:cNvPr id="8" name="Text 6"/>
+          <p:cNvSpPr/>
+          <p:nvPr/>
+        </p:nvSpPr>
+        <p:spPr>
+          <a:xfrm>
+            <a:off x="822960" y="4114800"/>
+            <a:ext cx="10515600" cy="502920"/>
+          </a:xfrm>
+          <a:prstGeom prst="rect">
+            <a:avLst/>
+          </a:prstGeom>
+          <a:noFill/>
+          <a:ln/>
+        </p:spPr>
+        <p:txBody>
+          <a:bodyPr wrap="square" lIns="0" tIns="0" rIns="0" bIns="0" rtlCol="0" anchor="ctr"/>
+          <a:lstStyle/>
+          <a:p>
+            <a:pPr algn="l" indent="0" marL="0">
+              <a:buNone/>
+            </a:pPr>
+            <a:r>
+              <a:rPr lang="en-US" sz="1100" i="1" dirty="0">
+                <a:solidFill>
+                  <a:srgbClr val="6B7480"/>
+                </a:solidFill>
+                <a:latin typeface="Garamond" pitchFamily="34" charset="0"/>
+                <a:ea typeface="Garamond" pitchFamily="34" charset="-122"/>
+                <a:cs typeface="Garamond" pitchFamily="34" charset="-120"/>
+              </a:rPr>
+              <a:t>Never included (they carry their own codes, outside the set):  postsecondary teachers (2200s)  ·  tutors (2350, 2018 cl.)  ·  teaching assistants (2540/2545)  ·  childcare workers (4600)  ·  education administrators (0230)</a:t>
+            </a:r>
+            <a:endParaRPr lang="en-US" sz="1100" dirty="0"/>
+          </a:p>
+        </p:txBody>
+      </p:sp>
+      <p:sp>
+        <p:nvSpPr>
+          <p:cNvPr id="9" name="Text 7"/>
+          <p:cNvSpPr/>
+          <p:nvPr/>
+        </p:nvSpPr>
+        <p:spPr>
+          <a:xfrm>
+            <a:off x="822960" y="4663440"/>
+            <a:ext cx="10515600" cy="320040"/>
+          </a:xfrm>
+          <a:prstGeom prst="rect">
+            <a:avLst/>
+          </a:prstGeom>
+          <a:noFill/>
+          <a:ln/>
+        </p:spPr>
+        <p:txBody>
+          <a:bodyPr wrap="square" lIns="0" tIns="0" rIns="0" bIns="0" rtlCol="0" anchor="ctr"/>
+          <a:lstStyle/>
+          <a:p>
+            <a:pPr algn="l" indent="0" marL="0">
+              <a:buNone/>
+            </a:pPr>
+            <a:r>
+              <a:rPr lang="en-US" sz="1500" b="1" dirty="0">
+                <a:solidFill>
+                  <a:srgbClr val="00549F"/>
+                </a:solidFill>
+                <a:latin typeface="Garamond" pitchFamily="34" charset="0"/>
+                <a:ea typeface="Garamond" pitchFamily="34" charset="-122"/>
+                <a:cs typeface="Garamond" pitchFamily="34" charset="-120"/>
+              </a:rPr>
+              <a:t>Are the codes traceable across census years?</a:t>
+            </a:r>
+            <a:endParaRPr lang="en-US" sz="1500" dirty="0"/>
+          </a:p>
+        </p:txBody>
+      </p:sp>
+      <p:sp>
+        <p:nvSpPr>
+          <p:cNvPr id="10" name="Text 8"/>
+          <p:cNvSpPr/>
+          <p:nvPr/>
+        </p:nvSpPr>
+        <p:spPr>
+          <a:xfrm>
+            <a:off x="822960" y="5029200"/>
+            <a:ext cx="10515600" cy="1737360"/>
+          </a:xfrm>
+          <a:prstGeom prst="rect">
+            <a:avLst/>
+          </a:prstGeom>
+          <a:noFill/>
+          <a:ln/>
+        </p:spPr>
+        <p:txBody>
+          <a:bodyPr wrap="square" lIns="0" tIns="0" rIns="0" bIns="0" rtlCol="0" anchor="t"/>
+          <a:lstStyle/>
+          <a:p>
+            <a:pPr algn="l" indent="0" marL="0">
+              <a:buNone/>
+            </a:pPr>
+            <a:r>
+              <a:rPr lang="en-US" sz="1100" b="1" dirty="0">
+                <a:solidFill>
+                  <a:srgbClr val="3A8A62"/>
+                </a:solidFill>
+                <a:latin typeface="Garamond" pitchFamily="34" charset="0"/>
+                <a:ea typeface="Garamond" pitchFamily="34" charset="-122"/>
+                <a:cs typeface="Garamond" pitchFamily="34" charset="-120"/>
+              </a:rPr>
+              <a:t>Yes  </a:t>
+            </a:r>
+            <a:pPr algn="l" indent="0" marL="0">
+              <a:spcAft>
+                <a:spcPts val="600"/>
+              </a:spcAft>
+              <a:buNone/>
+            </a:pPr>
+            <a:r>
+              <a:rPr lang="en-US" sz="1100" dirty="0">
+                <a:solidFill>
+                  <a:srgbClr val="1A2430"/>
+                </a:solidFill>
+                <a:latin typeface="Garamond" pitchFamily="34" charset="0"/>
+                <a:ea typeface="Garamond" pitchFamily="34" charset="-122"/>
+                <a:cs typeface="Garamond" pitchFamily="34" charset="-120"/>
+              </a:rPr>
+              <a:t>as a block: the K–12 teaching group maps one-to-one across the three classifications — every figure uses the union of the codes, never a sub-code across regimes.</a:t>
+            </a:r>
+            <a:endParaRPr lang="en-US" sz="1100" dirty="0"/>
+          </a:p>
+          <a:p>
+            <a:pPr algn="l" indent="0" marL="0">
+              <a:buNone/>
+            </a:pPr>
+            <a:r>
+              <a:rPr lang="en-US" sz="1100" b="1" dirty="0">
+                <a:solidFill>
+                  <a:srgbClr val="B5443C"/>
+                </a:solidFill>
+                <a:latin typeface="Garamond" pitchFamily="34" charset="0"/>
+                <a:ea typeface="Garamond" pitchFamily="34" charset="-122"/>
+                <a:cs typeface="Garamond" pitchFamily="34" charset="-120"/>
+              </a:rPr>
+              <a:t>†  </a:t>
+            </a:r>
+            <a:pPr algn="l" indent="0" marL="0">
+              <a:spcAft>
+                <a:spcPts val="600"/>
+              </a:spcAft>
+              <a:buNone/>
+            </a:pPr>
+            <a:r>
+              <a:rPr lang="en-US" sz="1100" dirty="0">
+                <a:solidFill>
+                  <a:srgbClr val="1A2430"/>
+                </a:solidFill>
+                <a:latin typeface="Garamond" pitchFamily="34" charset="0"/>
+                <a:ea typeface="Garamond" pitchFamily="34" charset="-122"/>
+                <a:cs typeface="Garamond" pitchFamily="34" charset="-120"/>
+              </a:rPr>
+              <a:t>sub-codes are not: middle-school teachers sit under elementary or secondary before 2003 and with elementary (2310) after; “other teachers” is renumbered 2340 → 2360 in 2020.</a:t>
+            </a:r>
+            <a:endParaRPr lang="en-US" sz="1100" dirty="0"/>
+          </a:p>
+          <a:p>
+            <a:pPr algn="l" indent="0" marL="0">
+              <a:buNone/>
+            </a:pPr>
+            <a:r>
+              <a:rPr lang="en-US" sz="1100" b="1" dirty="0">
+                <a:solidFill>
+                  <a:srgbClr val="3A8A62"/>
+                </a:solidFill>
+                <a:latin typeface="Garamond" pitchFamily="34" charset="0"/>
+                <a:ea typeface="Garamond" pitchFamily="34" charset="-122"/>
+                <a:cs typeface="Garamond" pitchFamily="34" charset="-120"/>
+              </a:rPr>
+              <a:t>Yes  </a:t>
+            </a:r>
+            <a:pPr algn="l" indent="0" marL="0">
+              <a:spcAft>
+                <a:spcPts val="600"/>
+              </a:spcAft>
+              <a:buNone/>
+            </a:pPr>
+            <a:r>
+              <a:rPr lang="en-US" sz="1100" dirty="0">
+                <a:solidFill>
+                  <a:srgbClr val="1A2430"/>
+                </a:solidFill>
+                <a:latin typeface="Garamond" pitchFamily="34" charset="0"/>
+                <a:ea typeface="Garamond" pitchFamily="34" charset="-122"/>
+                <a:cs typeface="Garamond" pitchFamily="34" charset="-120"/>
+              </a:rPr>
+              <a:t>within each survey: last year’s job (OCCUP) and the current job (PEIOOCC) share one classification, so no leaver/switch comparison straddles a code change (seams: 2003, 2020).</a:t>
+            </a:r>
+            <a:endParaRPr lang="en-US" sz="1100" dirty="0"/>
+          </a:p>
+          <a:p>
+            <a:pPr algn="l" indent="0" marL="0">
+              <a:buNone/>
+            </a:pPr>
+            <a:r>
+              <a:rPr lang="en-US" sz="1100" b="1" dirty="0">
+                <a:solidFill>
+                  <a:srgbClr val="3A8A62"/>
+                </a:solidFill>
+                <a:latin typeface="Garamond" pitchFamily="34" charset="0"/>
+                <a:ea typeface="Garamond" pitchFamily="34" charset="-122"/>
+                <a:cs typeface="Garamond" pitchFamily="34" charset="-120"/>
+              </a:rPr>
+              <a:t>Yes  </a:t>
+            </a:r>
+            <a:pPr algn="l" indent="0" marL="0">
+              <a:spcAft>
+                <a:spcPts val="600"/>
+              </a:spcAft>
+              <a:buNone/>
+            </a:pPr>
+            <a:r>
+              <a:rPr lang="en-US" sz="1100" dirty="0">
+                <a:solidFill>
+                  <a:srgbClr val="1A2430"/>
+                </a:solidFill>
+                <a:latin typeface="Garamond" pitchFamily="34" charset="0"/>
+                <a:ea typeface="Garamond" pitchFamily="34" charset="-122"/>
+                <a:cs typeface="Garamond" pitchFamily="34" charset="-120"/>
+              </a:rPr>
+              <a:t>for people, but only two years: the CPS links the same person across two consecutive March interviews (PERIDNUM), never longer.</a:t>
+            </a:r>
+            <a:endParaRPr lang="en-US" sz="1100" dirty="0"/>
+          </a:p>
+        </p:txBody>
+      </p:sp>
     </p:spTree>
   </p:cSld>
   <p:clrMapOvr>

</xml_diff>